<commit_message>
Fix alignment across the instructional-design deck
Verified every slide by rendering the PPTX to images (LibreOffice is
unavailable in this environment, so a lightweight python-pptx + PIL renderer
was used) and corrected: the cisco/SECURE logo lockup overlapping on every
slide, the title slide H1 colliding with the subtitle, Bloom level chips too
narrow for their labels, tofu check/cross glyphs replaced with font-safe
bullets, wrapped bullet lines, and a few over-tall cards.

Co-Authored-By: Claude Opus 4.8 <noreply@anthropic.com>
Claude-Session: https://claude.ai/code/session_01QFagQxWq3DUNgqxaEaNjHo
</commit_message>
<xml_diff>
--- a/deck/HMF-Design-Clinic-Activity.pptx
+++ b/deck/HMF-Design-Clinic-Activity.pptx
@@ -1506,7 +1506,7 @@
         </p:nvSpPr>
         <p:spPr>
           <a:xfrm>
-            <a:off x="548640" y="741274"/>
+            <a:off x="548640" y="695554"/>
             <a:ext cx="31090" cy="72542"/>
           </a:xfrm>
           <a:prstGeom prst="roundRect">
@@ -1528,7 +1528,7 @@
         </p:nvSpPr>
         <p:spPr>
           <a:xfrm>
-            <a:off x="601492" y="699821"/>
+            <a:off x="601492" y="654101"/>
             <a:ext cx="31090" cy="113995"/>
           </a:xfrm>
           <a:prstGeom prst="roundRect">
@@ -1550,7 +1550,7 @@
         </p:nvSpPr>
         <p:spPr>
           <a:xfrm>
-            <a:off x="654345" y="648005"/>
+            <a:off x="654345" y="602285"/>
             <a:ext cx="31090" cy="165811"/>
           </a:xfrm>
           <a:prstGeom prst="roundRect">
@@ -1572,7 +1572,7 @@
         </p:nvSpPr>
         <p:spPr>
           <a:xfrm>
-            <a:off x="707197" y="585826"/>
+            <a:off x="707197" y="540106"/>
             <a:ext cx="31090" cy="227990"/>
           </a:xfrm>
           <a:prstGeom prst="roundRect">
@@ -1594,7 +1594,7 @@
         </p:nvSpPr>
         <p:spPr>
           <a:xfrm>
-            <a:off x="760049" y="534010"/>
+            <a:off x="760049" y="488290"/>
             <a:ext cx="31090" cy="279806"/>
           </a:xfrm>
           <a:prstGeom prst="roundRect">
@@ -1616,7 +1616,7 @@
         </p:nvSpPr>
         <p:spPr>
           <a:xfrm>
-            <a:off x="812902" y="502920"/>
+            <a:off x="812902" y="457200"/>
             <a:ext cx="31090" cy="310896"/>
           </a:xfrm>
           <a:prstGeom prst="roundRect">
@@ -1638,7 +1638,7 @@
         </p:nvSpPr>
         <p:spPr>
           <a:xfrm>
-            <a:off x="865754" y="534010"/>
+            <a:off x="865754" y="488290"/>
             <a:ext cx="31090" cy="279806"/>
           </a:xfrm>
           <a:prstGeom prst="roundRect">
@@ -1660,7 +1660,7 @@
         </p:nvSpPr>
         <p:spPr>
           <a:xfrm>
-            <a:off x="918606" y="585826"/>
+            <a:off x="918606" y="540106"/>
             <a:ext cx="31090" cy="227990"/>
           </a:xfrm>
           <a:prstGeom prst="roundRect">
@@ -1682,7 +1682,7 @@
         </p:nvSpPr>
         <p:spPr>
           <a:xfrm>
-            <a:off x="971459" y="648005"/>
+            <a:off x="971459" y="602285"/>
             <a:ext cx="31090" cy="165811"/>
           </a:xfrm>
           <a:prstGeom prst="roundRect">
@@ -1704,7 +1704,7 @@
         </p:nvSpPr>
         <p:spPr>
           <a:xfrm>
-            <a:off x="1024311" y="699821"/>
+            <a:off x="1024311" y="654101"/>
             <a:ext cx="31090" cy="113995"/>
           </a:xfrm>
           <a:prstGeom prst="roundRect">
@@ -1726,7 +1726,7 @@
         </p:nvSpPr>
         <p:spPr>
           <a:xfrm>
-            <a:off x="1077163" y="741274"/>
+            <a:off x="1077163" y="695554"/>
             <a:ext cx="31090" cy="72542"/>
           </a:xfrm>
           <a:prstGeom prst="roundRect">
@@ -1748,8 +1748,8 @@
         </p:nvSpPr>
         <p:spPr>
           <a:xfrm>
-            <a:off x="1217066" y="429768"/>
-            <a:ext cx="1828800" cy="457200"/>
+            <a:off x="1235720" y="384048"/>
+            <a:ext cx="2194560" cy="457200"/>
           </a:xfrm>
           <a:prstGeom prst="rect">
             <a:avLst/>
@@ -1765,7 +1765,7 @@
               <a:buNone/>
             </a:pPr>
             <a:r>
-              <a:rPr lang="en-US" sz="2700" dirty="0">
+              <a:rPr lang="en-US" sz="2600" dirty="0">
                 <a:solidFill>
                   <a:srgbClr val="EEF4FB"/>
                 </a:solidFill>
@@ -1775,7 +1775,7 @@
               </a:rPr>
               <a:t>cisco</a:t>
             </a:r>
-            <a:endParaRPr lang="en-US" sz="2700" dirty="0"/>
+            <a:endParaRPr lang="en-US" sz="2600" dirty="0"/>
           </a:p>
         </p:txBody>
       </p:sp>
@@ -1787,8 +1787,8 @@
         </p:nvSpPr>
         <p:spPr>
           <a:xfrm>
-            <a:off x="1678381" y="429768"/>
-            <a:ext cx="1280160" cy="457200"/>
+            <a:off x="2133295" y="402336"/>
+            <a:ext cx="1463040" cy="420624"/>
           </a:xfrm>
           <a:prstGeom prst="rect">
             <a:avLst/>
@@ -1804,7 +1804,7 @@
               <a:buNone/>
             </a:pPr>
             <a:r>
-              <a:rPr lang="en-US" sz="1188" b="1" spc="200" kern="0" dirty="0">
+              <a:rPr lang="en-US" sz="1092" b="1" spc="150" kern="0" dirty="0">
                 <a:solidFill>
                   <a:srgbClr val="00BCEB"/>
                 </a:solidFill>
@@ -1814,7 +1814,7 @@
               </a:rPr>
               <a:t>SECURE</a:t>
             </a:r>
-            <a:endParaRPr lang="en-US" sz="1188" dirty="0"/>
+            <a:endParaRPr lang="en-US" sz="1092" dirty="0"/>
           </a:p>
         </p:txBody>
       </p:sp>
@@ -1826,7 +1826,7 @@
         </p:nvSpPr>
         <p:spPr>
           <a:xfrm>
-            <a:off x="548640" y="1874520"/>
+            <a:off x="548640" y="1828800"/>
             <a:ext cx="8229600" cy="320040"/>
           </a:xfrm>
           <a:prstGeom prst="rect">
@@ -1865,8 +1865,8 @@
         </p:nvSpPr>
         <p:spPr>
           <a:xfrm>
-            <a:off x="521208" y="2194560"/>
-            <a:ext cx="8961120" cy="1737360"/>
+            <a:off x="521208" y="2240280"/>
+            <a:ext cx="8686800" cy="868680"/>
           </a:xfrm>
           <a:prstGeom prst="rect">
             <a:avLst/>
@@ -1879,13 +1879,10 @@
           <a:lstStyle/>
           <a:p>
             <a:pPr algn="l" indent="0" marL="0">
-              <a:lnSpc>
-                <a:spcPct val="102000"/>
-              </a:lnSpc>
-              <a:buNone/>
-            </a:pPr>
-            <a:r>
-              <a:rPr lang="en-US" sz="4400" b="1" dirty="0">
+              <a:buNone/>
+            </a:pPr>
+            <a:r>
+              <a:rPr lang="en-US" sz="4800" b="1" dirty="0">
                 <a:solidFill>
                   <a:srgbClr val="EEF4FB"/>
                 </a:solidFill>
@@ -1895,17 +1892,36 @@
               </a:rPr>
               <a:t>HMF Design Clinic</a:t>
             </a:r>
-            <a:endParaRPr lang="en-US" sz="4400" dirty="0"/>
-          </a:p>
+            <a:endParaRPr lang="en-US" sz="4800" dirty="0"/>
+          </a:p>
+        </p:txBody>
+      </p:sp>
+      <p:sp>
+        <p:nvSpPr>
+          <p:cNvPr id="17" name="Text 15"/>
+          <p:cNvSpPr/>
+          <p:nvPr/>
+        </p:nvSpPr>
+        <p:spPr>
+          <a:xfrm>
+            <a:off x="548640" y="3154680"/>
+            <a:ext cx="8686800" cy="502920"/>
+          </a:xfrm>
+          <a:prstGeom prst="rect">
+            <a:avLst/>
+          </a:prstGeom>
+          <a:noFill/>
+          <a:ln/>
+        </p:spPr>
+        <p:txBody>
+          <a:bodyPr wrap="square" lIns="0" tIns="0" rIns="0" bIns="0" rtlCol="0" anchor="t"/>
+          <a:lstStyle/>
           <a:p>
             <a:pPr algn="l" indent="0" marL="0">
-              <a:lnSpc>
-                <a:spcPct val="102000"/>
-              </a:lnSpc>
-              <a:buNone/>
-            </a:pPr>
-            <a:r>
-              <a:rPr lang="en-US" sz="4400" b="1" dirty="0">
+              <a:buNone/>
+            </a:pPr>
+            <a:r>
+              <a:rPr lang="en-US" sz="2400" b="1" dirty="0">
                 <a:solidFill>
                   <a:srgbClr val="EEF4FB"/>
                 </a:solidFill>
@@ -1913,16 +1929,13 @@
                 <a:ea typeface="Calibri" pitchFamily="34" charset="-122"/>
                 <a:cs typeface="Calibri" pitchFamily="34" charset="-120"/>
               </a:rPr>
-              <a:t>An experiential </a:t>
+              <a:t>An experiential  </a:t>
             </a:r>
             <a:pPr algn="l" indent="0" marL="0">
-              <a:lnSpc>
-                <a:spcPct val="102000"/>
-              </a:lnSpc>
-              <a:buNone/>
-            </a:pPr>
-            <a:r>
-              <a:rPr lang="en-US" sz="4400" b="1" dirty="0">
+              <a:buNone/>
+            </a:pPr>
+            <a:r>
+              <a:rPr lang="en-US" sz="2400" b="1" dirty="0">
                 <a:solidFill>
                   <a:srgbClr val="00BCEB"/>
                 </a:solidFill>
@@ -1933,13 +1946,10 @@
               <a:t>45-minute</a:t>
             </a:r>
             <a:pPr algn="l" indent="0" marL="0">
-              <a:lnSpc>
-                <a:spcPct val="102000"/>
-              </a:lnSpc>
-              <a:buNone/>
-            </a:pPr>
-            <a:r>
-              <a:rPr lang="en-US" sz="4400" b="1" dirty="0">
+              <a:buNone/>
+            </a:pPr>
+            <a:r>
+              <a:rPr lang="en-US" sz="2400" b="1" dirty="0">
                 <a:solidFill>
                   <a:srgbClr val="EEF4FB"/>
                 </a:solidFill>
@@ -1947,22 +1957,22 @@
                 <a:ea typeface="Calibri" pitchFamily="34" charset="-122"/>
                 <a:cs typeface="Calibri" pitchFamily="34" charset="-120"/>
               </a:rPr>
-              <a:t> learning activity</a:t>
-            </a:r>
-            <a:endParaRPr lang="en-US" sz="4400" dirty="0"/>
-          </a:p>
-        </p:txBody>
-      </p:sp>
-      <p:sp>
-        <p:nvSpPr>
-          <p:cNvPr id="17" name="Text 15"/>
-          <p:cNvSpPr/>
-          <p:nvPr/>
-        </p:nvSpPr>
-        <p:spPr>
-          <a:xfrm>
-            <a:off x="548640" y="4069080"/>
-            <a:ext cx="7772400" cy="914400"/>
+              <a:t>  learning activity</a:t>
+            </a:r>
+            <a:endParaRPr lang="en-US" sz="2400" dirty="0"/>
+          </a:p>
+        </p:txBody>
+      </p:sp>
+      <p:sp>
+        <p:nvSpPr>
+          <p:cNvPr id="18" name="Text 16"/>
+          <p:cNvSpPr/>
+          <p:nvPr/>
+        </p:nvSpPr>
+        <p:spPr>
+          <a:xfrm>
+            <a:off x="548640" y="3886200"/>
+            <a:ext cx="7863840" cy="914400"/>
           </a:xfrm>
           <a:prstGeom prst="rect">
             <a:avLst/>
@@ -1997,7 +2007,7 @@
       </p:sp>
       <p:sp>
         <p:nvSpPr>
-          <p:cNvPr id="18" name="Shape 16"/>
+          <p:cNvPr id="19" name="Shape 17"/>
           <p:cNvSpPr/>
           <p:nvPr/>
         </p:nvSpPr>
@@ -2031,7 +2041,7 @@
       </p:sp>
       <p:sp>
         <p:nvSpPr>
-          <p:cNvPr id="19" name="Text 17"/>
+          <p:cNvPr id="20" name="Text 18"/>
           <p:cNvSpPr/>
           <p:nvPr/>
         </p:nvSpPr>
@@ -2070,7 +2080,7 @@
       </p:sp>
       <p:sp>
         <p:nvSpPr>
-          <p:cNvPr id="20" name="Text 18"/>
+          <p:cNvPr id="21" name="Text 19"/>
           <p:cNvSpPr/>
           <p:nvPr/>
         </p:nvSpPr>
@@ -2109,14 +2119,14 @@
       </p:sp>
       <p:sp>
         <p:nvSpPr>
-          <p:cNvPr id="21" name="Shape 19"/>
-          <p:cNvSpPr/>
-          <p:nvPr/>
-        </p:nvSpPr>
-        <p:spPr>
-          <a:xfrm>
-            <a:off x="548640" y="5120640"/>
-            <a:ext cx="2618659" cy="310896"/>
+          <p:cNvPr id="22" name="Shape 20"/>
+          <p:cNvSpPr/>
+          <p:nvPr/>
+        </p:nvSpPr>
+        <p:spPr>
+          <a:xfrm>
+            <a:off x="548640" y="5257800"/>
+            <a:ext cx="2664379" cy="310896"/>
           </a:xfrm>
           <a:prstGeom prst="roundRect">
             <a:avLst>
@@ -2136,14 +2146,14 @@
       </p:sp>
       <p:sp>
         <p:nvSpPr>
-          <p:cNvPr id="22" name="Text 20"/>
-          <p:cNvSpPr/>
-          <p:nvPr/>
-        </p:nvSpPr>
-        <p:spPr>
-          <a:xfrm>
-            <a:off x="548640" y="5120640"/>
-            <a:ext cx="2618659" cy="310896"/>
+          <p:cNvPr id="23" name="Text 21"/>
+          <p:cNvSpPr/>
+          <p:nvPr/>
+        </p:nvSpPr>
+        <p:spPr>
+          <a:xfrm>
+            <a:off x="548640" y="5257800"/>
+            <a:ext cx="2664379" cy="310896"/>
           </a:xfrm>
           <a:prstGeom prst="rect">
             <a:avLst/>
@@ -2175,14 +2185,14 @@
       </p:sp>
       <p:sp>
         <p:nvSpPr>
-          <p:cNvPr id="23" name="Shape 21"/>
-          <p:cNvSpPr/>
-          <p:nvPr/>
-        </p:nvSpPr>
-        <p:spPr>
-          <a:xfrm>
-            <a:off x="3350179" y="5120640"/>
-            <a:ext cx="1830080" cy="310896"/>
+          <p:cNvPr id="24" name="Shape 22"/>
+          <p:cNvSpPr/>
+          <p:nvPr/>
+        </p:nvSpPr>
+        <p:spPr>
+          <a:xfrm>
+            <a:off x="3395899" y="5257800"/>
+            <a:ext cx="1875800" cy="310896"/>
           </a:xfrm>
           <a:prstGeom prst="roundRect">
             <a:avLst>
@@ -2202,14 +2212,14 @@
       </p:sp>
       <p:sp>
         <p:nvSpPr>
-          <p:cNvPr id="24" name="Text 22"/>
-          <p:cNvSpPr/>
-          <p:nvPr/>
-        </p:nvSpPr>
-        <p:spPr>
-          <a:xfrm>
-            <a:off x="3350179" y="5120640"/>
-            <a:ext cx="1830080" cy="310896"/>
+          <p:cNvPr id="25" name="Text 23"/>
+          <p:cNvSpPr/>
+          <p:nvPr/>
+        </p:nvSpPr>
+        <p:spPr>
+          <a:xfrm>
+            <a:off x="3395899" y="5257800"/>
+            <a:ext cx="1875800" cy="310896"/>
           </a:xfrm>
           <a:prstGeom prst="rect">
             <a:avLst/>
@@ -2241,14 +2251,14 @@
       </p:sp>
       <p:sp>
         <p:nvSpPr>
-          <p:cNvPr id="25" name="Shape 23"/>
-          <p:cNvSpPr/>
-          <p:nvPr/>
-        </p:nvSpPr>
-        <p:spPr>
-          <a:xfrm>
-            <a:off x="5363139" y="5120640"/>
-            <a:ext cx="2618659" cy="310896"/>
+          <p:cNvPr id="26" name="Shape 24"/>
+          <p:cNvSpPr/>
+          <p:nvPr/>
+        </p:nvSpPr>
+        <p:spPr>
+          <a:xfrm>
+            <a:off x="5454579" y="5257800"/>
+            <a:ext cx="2664379" cy="310896"/>
           </a:xfrm>
           <a:prstGeom prst="roundRect">
             <a:avLst>
@@ -2268,14 +2278,14 @@
       </p:sp>
       <p:sp>
         <p:nvSpPr>
-          <p:cNvPr id="26" name="Text 24"/>
-          <p:cNvSpPr/>
-          <p:nvPr/>
-        </p:nvSpPr>
-        <p:spPr>
-          <a:xfrm>
-            <a:off x="5363139" y="5120640"/>
-            <a:ext cx="2618659" cy="310896"/>
+          <p:cNvPr id="27" name="Text 25"/>
+          <p:cNvSpPr/>
+          <p:nvPr/>
+        </p:nvSpPr>
+        <p:spPr>
+          <a:xfrm>
+            <a:off x="5454579" y="5257800"/>
+            <a:ext cx="2664379" cy="310896"/>
           </a:xfrm>
           <a:prstGeom prst="rect">
             <a:avLst/>
@@ -2307,7 +2317,7 @@
       </p:sp>
       <p:sp>
         <p:nvSpPr>
-          <p:cNvPr id="27" name="Text 25"/>
+          <p:cNvPr id="28" name="Text 26"/>
           <p:cNvSpPr/>
           <p:nvPr/>
         </p:nvSpPr>
@@ -2536,11 +2546,11 @@
         <p:spPr>
           <a:xfrm>
             <a:off x="1463040" y="1773936"/>
-            <a:ext cx="969264" cy="384048"/>
+            <a:ext cx="1389888" cy="402336"/>
           </a:xfrm>
           <a:prstGeom prst="roundRect">
             <a:avLst>
-              <a:gd name="adj" fmla="val 21429"/>
+              <a:gd name="adj" fmla="val 20455"/>
             </a:avLst>
           </a:prstGeom>
           <a:solidFill>
@@ -2563,7 +2573,7 @@
         <p:spPr>
           <a:xfrm>
             <a:off x="1463040" y="1773936"/>
-            <a:ext cx="969264" cy="384048"/>
+            <a:ext cx="1389888" cy="402336"/>
           </a:xfrm>
           <a:prstGeom prst="rect">
             <a:avLst/>
@@ -2579,7 +2589,7 @@
               <a:buNone/>
             </a:pPr>
             <a:r>
-              <a:rPr lang="en-US" sz="1100" b="1" spc="100" kern="0" dirty="0">
+              <a:rPr lang="en-US" sz="1100" b="1" spc="50" kern="0" dirty="0">
                 <a:solidFill>
                   <a:srgbClr val="00BCEB"/>
                 </a:solidFill>
@@ -2759,11 +2769,11 @@
         <p:spPr>
           <a:xfrm>
             <a:off x="1463040" y="2834640"/>
-            <a:ext cx="640080" cy="384048"/>
+            <a:ext cx="886968" cy="402336"/>
           </a:xfrm>
           <a:prstGeom prst="roundRect">
             <a:avLst>
-              <a:gd name="adj" fmla="val 21429"/>
+              <a:gd name="adj" fmla="val 20455"/>
             </a:avLst>
           </a:prstGeom>
           <a:solidFill>
@@ -2786,7 +2796,7 @@
         <p:spPr>
           <a:xfrm>
             <a:off x="1463040" y="2834640"/>
-            <a:ext cx="640080" cy="384048"/>
+            <a:ext cx="886968" cy="402336"/>
           </a:xfrm>
           <a:prstGeom prst="rect">
             <a:avLst/>
@@ -2802,7 +2812,7 @@
               <a:buNone/>
             </a:pPr>
             <a:r>
-              <a:rPr lang="en-US" sz="1100" b="1" spc="100" kern="0" dirty="0">
+              <a:rPr lang="en-US" sz="1100" b="1" spc="50" kern="0" dirty="0">
                 <a:solidFill>
                   <a:srgbClr val="2FBE86"/>
                 </a:solidFill>
@@ -2982,11 +2992,11 @@
         <p:spPr>
           <a:xfrm>
             <a:off x="1463040" y="3895344"/>
-            <a:ext cx="771754" cy="384048"/>
+            <a:ext cx="1088136" cy="402336"/>
           </a:xfrm>
           <a:prstGeom prst="roundRect">
             <a:avLst>
-              <a:gd name="adj" fmla="val 21429"/>
+              <a:gd name="adj" fmla="val 20455"/>
             </a:avLst>
           </a:prstGeom>
           <a:solidFill>
@@ -3009,7 +3019,7 @@
         <p:spPr>
           <a:xfrm>
             <a:off x="1463040" y="3895344"/>
-            <a:ext cx="771754" cy="384048"/>
+            <a:ext cx="1088136" cy="402336"/>
           </a:xfrm>
           <a:prstGeom prst="rect">
             <a:avLst/>
@@ -3025,7 +3035,7 @@
               <a:buNone/>
             </a:pPr>
             <a:r>
-              <a:rPr lang="en-US" sz="1100" b="1" spc="100" kern="0" dirty="0">
+              <a:rPr lang="en-US" sz="1100" b="1" spc="50" kern="0" dirty="0">
                 <a:solidFill>
                   <a:srgbClr val="F0A22E"/>
                 </a:solidFill>
@@ -3205,11 +3215,11 @@
         <p:spPr>
           <a:xfrm>
             <a:off x="1463040" y="4956048"/>
-            <a:ext cx="705917" cy="384048"/>
+            <a:ext cx="987552" cy="402336"/>
           </a:xfrm>
           <a:prstGeom prst="roundRect">
             <a:avLst>
-              <a:gd name="adj" fmla="val 21429"/>
+              <a:gd name="adj" fmla="val 20455"/>
             </a:avLst>
           </a:prstGeom>
           <a:solidFill>
@@ -3232,7 +3242,7 @@
         <p:spPr>
           <a:xfrm>
             <a:off x="1463040" y="4956048"/>
-            <a:ext cx="705917" cy="384048"/>
+            <a:ext cx="987552" cy="402336"/>
           </a:xfrm>
           <a:prstGeom prst="rect">
             <a:avLst/>
@@ -3248,7 +3258,7 @@
               <a:buNone/>
             </a:pPr>
             <a:r>
-              <a:rPr lang="en-US" sz="1100" b="1" spc="100" kern="0" dirty="0">
+              <a:rPr lang="en-US" sz="1100" b="1" spc="50" kern="0" dirty="0">
                 <a:solidFill>
                   <a:srgbClr val="FFC663"/>
                 </a:solidFill>
@@ -3638,8 +3648,8 @@
         </p:nvSpPr>
         <p:spPr>
           <a:xfrm>
-            <a:off x="863194" y="6254496"/>
-            <a:ext cx="1828800" cy="292608"/>
+            <a:off x="871972" y="6254496"/>
+            <a:ext cx="2194560" cy="292608"/>
           </a:xfrm>
           <a:prstGeom prst="rect">
             <a:avLst/>
@@ -3677,8 +3687,8 @@
         </p:nvSpPr>
         <p:spPr>
           <a:xfrm>
-            <a:off x="1139342" y="6254496"/>
-            <a:ext cx="1280160" cy="292608"/>
+            <a:off x="1365016" y="6272784"/>
+            <a:ext cx="1463040" cy="256032"/>
           </a:xfrm>
           <a:prstGeom prst="rect">
             <a:avLst/>
@@ -3694,7 +3704,7 @@
               <a:buNone/>
             </a:pPr>
             <a:r>
-              <a:rPr lang="en-US" sz="528" b="1" spc="200" kern="0" dirty="0">
+              <a:rPr lang="en-US" sz="504" b="1" spc="150" kern="0" dirty="0">
                 <a:solidFill>
                   <a:srgbClr val="00BCEB"/>
                 </a:solidFill>
@@ -3704,7 +3714,7 @@
               </a:rPr>
               <a:t>SECURE</a:t>
             </a:r>
-            <a:endParaRPr lang="en-US" sz="528" dirty="0"/>
+            <a:endParaRPr lang="en-US" sz="504" dirty="0"/>
           </a:p>
         </p:txBody>
       </p:sp>
@@ -5216,8 +5226,8 @@
         </p:nvSpPr>
         <p:spPr>
           <a:xfrm>
-            <a:off x="863194" y="6254496"/>
-            <a:ext cx="1828800" cy="292608"/>
+            <a:off x="871972" y="6254496"/>
+            <a:ext cx="2194560" cy="292608"/>
           </a:xfrm>
           <a:prstGeom prst="rect">
             <a:avLst/>
@@ -5255,8 +5265,8 @@
         </p:nvSpPr>
         <p:spPr>
           <a:xfrm>
-            <a:off x="1139342" y="6254496"/>
-            <a:ext cx="1280160" cy="292608"/>
+            <a:off x="1365016" y="6272784"/>
+            <a:ext cx="1463040" cy="256032"/>
           </a:xfrm>
           <a:prstGeom prst="rect">
             <a:avLst/>
@@ -5272,7 +5282,7 @@
               <a:buNone/>
             </a:pPr>
             <a:r>
-              <a:rPr lang="en-US" sz="528" b="1" spc="200" kern="0" dirty="0">
+              <a:rPr lang="en-US" sz="504" b="1" spc="150" kern="0" dirty="0">
                 <a:solidFill>
                   <a:srgbClr val="00BCEB"/>
                 </a:solidFill>
@@ -5282,7 +5292,7 @@
               </a:rPr>
               <a:t>SECURE</a:t>
             </a:r>
-            <a:endParaRPr lang="en-US" sz="528" dirty="0"/>
+            <a:endParaRPr lang="en-US" sz="504" dirty="0"/>
           </a:p>
         </p:txBody>
       </p:sp>
@@ -5443,8 +5453,8 @@
         </p:nvSpPr>
         <p:spPr>
           <a:xfrm>
-            <a:off x="548640" y="1554480"/>
-            <a:ext cx="1975104" cy="3657600"/>
+            <a:off x="548640" y="1508760"/>
+            <a:ext cx="1975104" cy="3154680"/>
           </a:xfrm>
           <a:prstGeom prst="roundRect">
             <a:avLst>
@@ -5477,7 +5487,7 @@
         </p:nvSpPr>
         <p:spPr>
           <a:xfrm>
-            <a:off x="749808" y="1755648"/>
+            <a:off x="749808" y="1709928"/>
             <a:ext cx="973653" cy="274320"/>
           </a:xfrm>
           <a:prstGeom prst="roundRect">
@@ -5504,7 +5514,7 @@
         </p:nvSpPr>
         <p:spPr>
           <a:xfrm>
-            <a:off x="749808" y="1755648"/>
+            <a:off x="749808" y="1709928"/>
             <a:ext cx="973653" cy="274320"/>
           </a:xfrm>
           <a:prstGeom prst="rect">
@@ -5543,7 +5553,7 @@
         </p:nvSpPr>
         <p:spPr>
           <a:xfrm>
-            <a:off x="749808" y="2121408"/>
+            <a:off x="749808" y="2075688"/>
             <a:ext cx="1572768" cy="274320"/>
           </a:xfrm>
           <a:prstGeom prst="rect">
@@ -5582,7 +5592,7 @@
         </p:nvSpPr>
         <p:spPr>
           <a:xfrm>
-            <a:off x="749808" y="2423160"/>
+            <a:off x="749808" y="2377440"/>
             <a:ext cx="1572768" cy="603504"/>
           </a:xfrm>
           <a:prstGeom prst="rect">
@@ -5602,7 +5612,7 @@
               <a:buNone/>
             </a:pPr>
             <a:r>
-              <a:rPr lang="en-US" sz="1550" b="1" dirty="0">
+              <a:rPr lang="en-US" sz="1500" b="1" dirty="0">
                 <a:solidFill>
                   <a:srgbClr val="EEF4FB"/>
                 </a:solidFill>
@@ -5612,7 +5622,7 @@
               </a:rPr>
               <a:t>Get set up</a:t>
             </a:r>
-            <a:endParaRPr lang="en-US" sz="1550" dirty="0"/>
+            <a:endParaRPr lang="en-US" sz="1500" dirty="0"/>
           </a:p>
         </p:txBody>
       </p:sp>
@@ -5624,8 +5634,8 @@
         </p:nvSpPr>
         <p:spPr>
           <a:xfrm>
-            <a:off x="749808" y="3035808"/>
-            <a:ext cx="1572768" cy="2103120"/>
+            <a:off x="749808" y="2990088"/>
+            <a:ext cx="1572768" cy="1600200"/>
           </a:xfrm>
           <a:prstGeom prst="rect">
             <a:avLst/>
@@ -5666,8 +5676,8 @@
         </p:nvSpPr>
         <p:spPr>
           <a:xfrm>
-            <a:off x="2505456" y="1554480"/>
-            <a:ext cx="301752" cy="3657600"/>
+            <a:off x="2505456" y="1508760"/>
+            <a:ext cx="301752" cy="3154680"/>
           </a:xfrm>
           <a:prstGeom prst="rect">
             <a:avLst/>
@@ -5705,8 +5715,8 @@
         </p:nvSpPr>
         <p:spPr>
           <a:xfrm>
-            <a:off x="2825496" y="1554480"/>
-            <a:ext cx="1975104" cy="3657600"/>
+            <a:off x="2825496" y="1508760"/>
+            <a:ext cx="1975104" cy="3154680"/>
           </a:xfrm>
           <a:prstGeom prst="roundRect">
             <a:avLst>
@@ -5739,7 +5749,7 @@
         </p:nvSpPr>
         <p:spPr>
           <a:xfrm>
-            <a:off x="3026664" y="1755648"/>
+            <a:off x="3026664" y="1709928"/>
             <a:ext cx="973653" cy="274320"/>
           </a:xfrm>
           <a:prstGeom prst="roundRect">
@@ -5766,7 +5776,7 @@
         </p:nvSpPr>
         <p:spPr>
           <a:xfrm>
-            <a:off x="3026664" y="1755648"/>
+            <a:off x="3026664" y="1709928"/>
             <a:ext cx="973653" cy="274320"/>
           </a:xfrm>
           <a:prstGeom prst="rect">
@@ -5805,7 +5815,7 @@
         </p:nvSpPr>
         <p:spPr>
           <a:xfrm>
-            <a:off x="3026664" y="2121408"/>
+            <a:off x="3026664" y="2075688"/>
             <a:ext cx="1572768" cy="274320"/>
           </a:xfrm>
           <a:prstGeom prst="rect">
@@ -5844,7 +5854,7 @@
         </p:nvSpPr>
         <p:spPr>
           <a:xfrm>
-            <a:off x="3026664" y="2423160"/>
+            <a:off x="3026664" y="2377440"/>
             <a:ext cx="1572768" cy="603504"/>
           </a:xfrm>
           <a:prstGeom prst="rect">
@@ -5864,7 +5874,7 @@
               <a:buNone/>
             </a:pPr>
             <a:r>
-              <a:rPr lang="en-US" sz="1550" b="1" dirty="0">
+              <a:rPr lang="en-US" sz="1500" b="1" dirty="0">
                 <a:solidFill>
                   <a:srgbClr val="EEF4FB"/>
                 </a:solidFill>
@@ -5874,7 +5884,7 @@
               </a:rPr>
               <a:t>Four case studies</a:t>
             </a:r>
-            <a:endParaRPr lang="en-US" sz="1550" dirty="0"/>
+            <a:endParaRPr lang="en-US" sz="1500" dirty="0"/>
           </a:p>
         </p:txBody>
       </p:sp>
@@ -5886,8 +5896,8 @@
         </p:nvSpPr>
         <p:spPr>
           <a:xfrm>
-            <a:off x="3026664" y="3035808"/>
-            <a:ext cx="1572768" cy="2103120"/>
+            <a:off x="3026664" y="2990088"/>
+            <a:ext cx="1572768" cy="1600200"/>
           </a:xfrm>
           <a:prstGeom prst="rect">
             <a:avLst/>
@@ -5928,8 +5938,8 @@
         </p:nvSpPr>
         <p:spPr>
           <a:xfrm>
-            <a:off x="4782312" y="1554480"/>
-            <a:ext cx="301752" cy="3657600"/>
+            <a:off x="4782312" y="1508760"/>
+            <a:ext cx="301752" cy="3154680"/>
           </a:xfrm>
           <a:prstGeom prst="rect">
             <a:avLst/>
@@ -5967,8 +5977,8 @@
         </p:nvSpPr>
         <p:spPr>
           <a:xfrm>
-            <a:off x="5102352" y="1554480"/>
-            <a:ext cx="1975104" cy="3657600"/>
+            <a:off x="5102352" y="1508760"/>
+            <a:ext cx="1975104" cy="3154680"/>
           </a:xfrm>
           <a:prstGeom prst="roundRect">
             <a:avLst>
@@ -6001,7 +6011,7 @@
         </p:nvSpPr>
         <p:spPr>
           <a:xfrm>
-            <a:off x="5303520" y="1755648"/>
+            <a:off x="5303520" y="1709928"/>
             <a:ext cx="1143914" cy="274320"/>
           </a:xfrm>
           <a:prstGeom prst="roundRect">
@@ -6028,7 +6038,7 @@
         </p:nvSpPr>
         <p:spPr>
           <a:xfrm>
-            <a:off x="5303520" y="1755648"/>
+            <a:off x="5303520" y="1709928"/>
             <a:ext cx="1143914" cy="274320"/>
           </a:xfrm>
           <a:prstGeom prst="rect">
@@ -6067,7 +6077,7 @@
         </p:nvSpPr>
         <p:spPr>
           <a:xfrm>
-            <a:off x="5303520" y="2121408"/>
+            <a:off x="5303520" y="2075688"/>
             <a:ext cx="1572768" cy="274320"/>
           </a:xfrm>
           <a:prstGeom prst="rect">
@@ -6106,7 +6116,7 @@
         </p:nvSpPr>
         <p:spPr>
           <a:xfrm>
-            <a:off x="5303520" y="2423160"/>
+            <a:off x="5303520" y="2377440"/>
             <a:ext cx="1572768" cy="603504"/>
           </a:xfrm>
           <a:prstGeom prst="rect">
@@ -6126,7 +6136,7 @@
               <a:buNone/>
             </a:pPr>
             <a:r>
-              <a:rPr lang="en-US" sz="1550" b="1" dirty="0">
+              <a:rPr lang="en-US" sz="1500" b="1" dirty="0">
                 <a:solidFill>
                   <a:srgbClr val="EEF4FB"/>
                 </a:solidFill>
@@ -6136,7 +6146,7 @@
               </a:rPr>
               <a:t>Flipchart story</a:t>
             </a:r>
-            <a:endParaRPr lang="en-US" sz="1550" dirty="0"/>
+            <a:endParaRPr lang="en-US" sz="1500" dirty="0"/>
           </a:p>
         </p:txBody>
       </p:sp>
@@ -6148,8 +6158,8 @@
         </p:nvSpPr>
         <p:spPr>
           <a:xfrm>
-            <a:off x="5303520" y="3035808"/>
-            <a:ext cx="1572768" cy="2103120"/>
+            <a:off x="5303520" y="2990088"/>
+            <a:ext cx="1572768" cy="1600200"/>
           </a:xfrm>
           <a:prstGeom prst="rect">
             <a:avLst/>
@@ -6190,8 +6200,8 @@
         </p:nvSpPr>
         <p:spPr>
           <a:xfrm>
-            <a:off x="7059168" y="1554480"/>
-            <a:ext cx="301752" cy="3657600"/>
+            <a:off x="7059168" y="1508760"/>
+            <a:ext cx="301752" cy="3154680"/>
           </a:xfrm>
           <a:prstGeom prst="rect">
             <a:avLst/>
@@ -6229,8 +6239,8 @@
         </p:nvSpPr>
         <p:spPr>
           <a:xfrm>
-            <a:off x="7379208" y="1554480"/>
-            <a:ext cx="1975104" cy="3657600"/>
+            <a:off x="7379208" y="1508760"/>
+            <a:ext cx="1975104" cy="3154680"/>
           </a:xfrm>
           <a:prstGeom prst="roundRect">
             <a:avLst>
@@ -6263,7 +6273,7 @@
         </p:nvSpPr>
         <p:spPr>
           <a:xfrm>
-            <a:off x="7580376" y="1755648"/>
+            <a:off x="7580376" y="1709928"/>
             <a:ext cx="888522" cy="274320"/>
           </a:xfrm>
           <a:prstGeom prst="roundRect">
@@ -6290,7 +6300,7 @@
         </p:nvSpPr>
         <p:spPr>
           <a:xfrm>
-            <a:off x="7580376" y="1755648"/>
+            <a:off x="7580376" y="1709928"/>
             <a:ext cx="888522" cy="274320"/>
           </a:xfrm>
           <a:prstGeom prst="rect">
@@ -6329,7 +6339,7 @@
         </p:nvSpPr>
         <p:spPr>
           <a:xfrm>
-            <a:off x="7580376" y="2121408"/>
+            <a:off x="7580376" y="2075688"/>
             <a:ext cx="1572768" cy="274320"/>
           </a:xfrm>
           <a:prstGeom prst="rect">
@@ -6368,7 +6378,7 @@
         </p:nvSpPr>
         <p:spPr>
           <a:xfrm>
-            <a:off x="7580376" y="2423160"/>
+            <a:off x="7580376" y="2377440"/>
             <a:ext cx="1572768" cy="603504"/>
           </a:xfrm>
           <a:prstGeom prst="rect">
@@ -6388,7 +6398,7 @@
               <a:buNone/>
             </a:pPr>
             <a:r>
-              <a:rPr lang="en-US" sz="1550" b="1" dirty="0">
+              <a:rPr lang="en-US" sz="1500" b="1" dirty="0">
                 <a:solidFill>
                   <a:srgbClr val="EEF4FB"/>
                 </a:solidFill>
@@ -6398,7 +6408,7 @@
               </a:rPr>
               <a:t>Capture &amp; convert</a:t>
             </a:r>
-            <a:endParaRPr lang="en-US" sz="1550" dirty="0"/>
+            <a:endParaRPr lang="en-US" sz="1500" dirty="0"/>
           </a:p>
         </p:txBody>
       </p:sp>
@@ -6410,8 +6420,8 @@
         </p:nvSpPr>
         <p:spPr>
           <a:xfrm>
-            <a:off x="7580376" y="3035808"/>
-            <a:ext cx="1572768" cy="2103120"/>
+            <a:off x="7580376" y="2990088"/>
+            <a:ext cx="1572768" cy="1600200"/>
           </a:xfrm>
           <a:prstGeom prst="rect">
             <a:avLst/>
@@ -6452,8 +6462,8 @@
         </p:nvSpPr>
         <p:spPr>
           <a:xfrm>
-            <a:off x="9336024" y="1554480"/>
-            <a:ext cx="301752" cy="3657600"/>
+            <a:off x="9336024" y="1508760"/>
+            <a:ext cx="301752" cy="3154680"/>
           </a:xfrm>
           <a:prstGeom prst="rect">
             <a:avLst/>
@@ -6491,8 +6501,8 @@
         </p:nvSpPr>
         <p:spPr>
           <a:xfrm>
-            <a:off x="9656064" y="1554480"/>
-            <a:ext cx="1975104" cy="3657600"/>
+            <a:off x="9656064" y="1508760"/>
+            <a:ext cx="1975104" cy="3154680"/>
           </a:xfrm>
           <a:prstGeom prst="roundRect">
             <a:avLst>
@@ -6525,7 +6535,7 @@
         </p:nvSpPr>
         <p:spPr>
           <a:xfrm>
-            <a:off x="9857232" y="1755648"/>
+            <a:off x="9857232" y="1709928"/>
             <a:ext cx="803392" cy="274320"/>
           </a:xfrm>
           <a:prstGeom prst="roundRect">
@@ -6552,7 +6562,7 @@
         </p:nvSpPr>
         <p:spPr>
           <a:xfrm>
-            <a:off x="9857232" y="1755648"/>
+            <a:off x="9857232" y="1709928"/>
             <a:ext cx="803392" cy="274320"/>
           </a:xfrm>
           <a:prstGeom prst="rect">
@@ -6591,7 +6601,7 @@
         </p:nvSpPr>
         <p:spPr>
           <a:xfrm>
-            <a:off x="9857232" y="2121408"/>
+            <a:off x="9857232" y="2075688"/>
             <a:ext cx="1572768" cy="274320"/>
           </a:xfrm>
           <a:prstGeom prst="rect">
@@ -6630,7 +6640,7 @@
         </p:nvSpPr>
         <p:spPr>
           <a:xfrm>
-            <a:off x="9857232" y="2423160"/>
+            <a:off x="9857232" y="2377440"/>
             <a:ext cx="1572768" cy="603504"/>
           </a:xfrm>
           <a:prstGeom prst="rect">
@@ -6650,7 +6660,7 @@
               <a:buNone/>
             </a:pPr>
             <a:r>
-              <a:rPr lang="en-US" sz="1550" b="1" dirty="0">
+              <a:rPr lang="en-US" sz="1500" b="1" dirty="0">
                 <a:solidFill>
                   <a:srgbClr val="EEF4FB"/>
                 </a:solidFill>
@@ -6660,7 +6670,7 @@
               </a:rPr>
               <a:t>Wrap &amp; score</a:t>
             </a:r>
-            <a:endParaRPr lang="en-US" sz="1550" dirty="0"/>
+            <a:endParaRPr lang="en-US" sz="1500" dirty="0"/>
           </a:p>
         </p:txBody>
       </p:sp>
@@ -6672,8 +6682,8 @@
         </p:nvSpPr>
         <p:spPr>
           <a:xfrm>
-            <a:off x="9857232" y="3035808"/>
-            <a:ext cx="1572768" cy="2103120"/>
+            <a:off x="9857232" y="2990088"/>
+            <a:ext cx="1572768" cy="1600200"/>
           </a:xfrm>
           <a:prstGeom prst="rect">
             <a:avLst/>
@@ -6714,12 +6724,12 @@
         </p:nvSpPr>
         <p:spPr>
           <a:xfrm>
-            <a:off x="548640" y="5440680"/>
-            <a:ext cx="11091672" cy="640080"/>
+            <a:off x="548640" y="4937760"/>
+            <a:ext cx="11091672" cy="822960"/>
           </a:xfrm>
           <a:prstGeom prst="roundRect">
             <a:avLst>
-              <a:gd name="adj" fmla="val 14286"/>
+              <a:gd name="adj" fmla="val 11111"/>
             </a:avLst>
           </a:prstGeom>
           <a:solidFill>
@@ -6735,14 +6745,36 @@
       </p:sp>
       <p:sp>
         <p:nvSpPr>
-          <p:cNvPr id="39" name="Text 37"/>
-          <p:cNvSpPr/>
-          <p:nvPr/>
-        </p:nvSpPr>
-        <p:spPr>
-          <a:xfrm>
-            <a:off x="822960" y="5440680"/>
-            <a:ext cx="10607040" cy="640080"/>
+          <p:cNvPr id="39" name="Shape 37"/>
+          <p:cNvSpPr/>
+          <p:nvPr/>
+        </p:nvSpPr>
+        <p:spPr>
+          <a:xfrm>
+            <a:off x="548640" y="4937760"/>
+            <a:ext cx="82296" cy="822960"/>
+          </a:xfrm>
+          <a:prstGeom prst="roundRect">
+            <a:avLst>
+              <a:gd name="adj" fmla="val 33333"/>
+            </a:avLst>
+          </a:prstGeom>
+          <a:solidFill>
+            <a:srgbClr val="00BCEB"/>
+          </a:solidFill>
+          <a:ln/>
+        </p:spPr>
+      </p:sp>
+      <p:sp>
+        <p:nvSpPr>
+          <p:cNvPr id="40" name="Text 38"/>
+          <p:cNvSpPr/>
+          <p:nvPr/>
+        </p:nvSpPr>
+        <p:spPr>
+          <a:xfrm>
+            <a:off x="868680" y="4937760"/>
+            <a:ext cx="10515600" cy="822960"/>
           </a:xfrm>
           <a:prstGeom prst="rect">
             <a:avLst/>
@@ -6794,7 +6826,7 @@
       </p:sp>
       <p:sp>
         <p:nvSpPr>
-          <p:cNvPr id="40" name="Shape 38"/>
+          <p:cNvPr id="41" name="Shape 39"/>
           <p:cNvSpPr/>
           <p:nvPr/>
         </p:nvSpPr>
@@ -6816,7 +6848,7 @@
       </p:sp>
       <p:sp>
         <p:nvSpPr>
-          <p:cNvPr id="41" name="Shape 39"/>
+          <p:cNvPr id="42" name="Shape 40"/>
           <p:cNvSpPr/>
           <p:nvPr/>
         </p:nvSpPr>
@@ -6838,7 +6870,7 @@
       </p:sp>
       <p:sp>
         <p:nvSpPr>
-          <p:cNvPr id="42" name="Shape 40"/>
+          <p:cNvPr id="43" name="Shape 41"/>
           <p:cNvSpPr/>
           <p:nvPr/>
         </p:nvSpPr>
@@ -6860,7 +6892,7 @@
       </p:sp>
       <p:sp>
         <p:nvSpPr>
-          <p:cNvPr id="43" name="Shape 41"/>
+          <p:cNvPr id="44" name="Shape 42"/>
           <p:cNvSpPr/>
           <p:nvPr/>
         </p:nvSpPr>
@@ -6882,7 +6914,7 @@
       </p:sp>
       <p:sp>
         <p:nvSpPr>
-          <p:cNvPr id="44" name="Shape 42"/>
+          <p:cNvPr id="45" name="Shape 43"/>
           <p:cNvSpPr/>
           <p:nvPr/>
         </p:nvSpPr>
@@ -6904,7 +6936,7 @@
       </p:sp>
       <p:sp>
         <p:nvSpPr>
-          <p:cNvPr id="45" name="Shape 43"/>
+          <p:cNvPr id="46" name="Shape 44"/>
           <p:cNvSpPr/>
           <p:nvPr/>
         </p:nvSpPr>
@@ -6926,7 +6958,7 @@
       </p:sp>
       <p:sp>
         <p:nvSpPr>
-          <p:cNvPr id="46" name="Shape 44"/>
+          <p:cNvPr id="47" name="Shape 45"/>
           <p:cNvSpPr/>
           <p:nvPr/>
         </p:nvSpPr>
@@ -6948,7 +6980,7 @@
       </p:sp>
       <p:sp>
         <p:nvSpPr>
-          <p:cNvPr id="47" name="Shape 45"/>
+          <p:cNvPr id="48" name="Shape 46"/>
           <p:cNvSpPr/>
           <p:nvPr/>
         </p:nvSpPr>
@@ -6970,7 +7002,7 @@
       </p:sp>
       <p:sp>
         <p:nvSpPr>
-          <p:cNvPr id="48" name="Shape 46"/>
+          <p:cNvPr id="49" name="Shape 47"/>
           <p:cNvSpPr/>
           <p:nvPr/>
         </p:nvSpPr>
@@ -6992,7 +7024,7 @@
       </p:sp>
       <p:sp>
         <p:nvSpPr>
-          <p:cNvPr id="49" name="Shape 47"/>
+          <p:cNvPr id="50" name="Shape 48"/>
           <p:cNvSpPr/>
           <p:nvPr/>
         </p:nvSpPr>
@@ -7014,7 +7046,7 @@
       </p:sp>
       <p:sp>
         <p:nvSpPr>
-          <p:cNvPr id="50" name="Shape 48"/>
+          <p:cNvPr id="51" name="Shape 49"/>
           <p:cNvSpPr/>
           <p:nvPr/>
         </p:nvSpPr>
@@ -7036,14 +7068,14 @@
       </p:sp>
       <p:sp>
         <p:nvSpPr>
-          <p:cNvPr id="51" name="Text 49"/>
-          <p:cNvSpPr/>
-          <p:nvPr/>
-        </p:nvSpPr>
-        <p:spPr>
-          <a:xfrm>
-            <a:off x="863194" y="6254496"/>
-            <a:ext cx="1828800" cy="292608"/>
+          <p:cNvPr id="52" name="Text 50"/>
+          <p:cNvSpPr/>
+          <p:nvPr/>
+        </p:nvSpPr>
+        <p:spPr>
+          <a:xfrm>
+            <a:off x="871972" y="6254496"/>
+            <a:ext cx="2194560" cy="292608"/>
           </a:xfrm>
           <a:prstGeom prst="rect">
             <a:avLst/>
@@ -7075,14 +7107,14 @@
       </p:sp>
       <p:sp>
         <p:nvSpPr>
-          <p:cNvPr id="52" name="Text 50"/>
-          <p:cNvSpPr/>
-          <p:nvPr/>
-        </p:nvSpPr>
-        <p:spPr>
-          <a:xfrm>
-            <a:off x="1139342" y="6254496"/>
-            <a:ext cx="1280160" cy="292608"/>
+          <p:cNvPr id="53" name="Text 51"/>
+          <p:cNvSpPr/>
+          <p:nvPr/>
+        </p:nvSpPr>
+        <p:spPr>
+          <a:xfrm>
+            <a:off x="1365016" y="6272784"/>
+            <a:ext cx="1463040" cy="256032"/>
           </a:xfrm>
           <a:prstGeom prst="rect">
             <a:avLst/>
@@ -7098,7 +7130,7 @@
               <a:buNone/>
             </a:pPr>
             <a:r>
-              <a:rPr lang="en-US" sz="528" b="1" spc="200" kern="0" dirty="0">
+              <a:rPr lang="en-US" sz="504" b="1" spc="150" kern="0" dirty="0">
                 <a:solidFill>
                   <a:srgbClr val="00BCEB"/>
                 </a:solidFill>
@@ -7108,13 +7140,13 @@
               </a:rPr>
               <a:t>SECURE</a:t>
             </a:r>
-            <a:endParaRPr lang="en-US" sz="528" dirty="0"/>
-          </a:p>
-        </p:txBody>
-      </p:sp>
-      <p:sp>
-        <p:nvSpPr>
-          <p:cNvPr id="53" name="Text 51"/>
+            <a:endParaRPr lang="en-US" sz="504" dirty="0"/>
+          </a:p>
+        </p:txBody>
+      </p:sp>
+      <p:sp>
+        <p:nvSpPr>
+          <p:cNvPr id="54" name="Text 52"/>
           <p:cNvSpPr/>
           <p:nvPr/>
         </p:nvSpPr>
@@ -8430,8 +8462,8 @@
         </p:nvSpPr>
         <p:spPr>
           <a:xfrm>
-            <a:off x="863194" y="6254496"/>
-            <a:ext cx="1828800" cy="292608"/>
+            <a:off x="871972" y="6254496"/>
+            <a:ext cx="2194560" cy="292608"/>
           </a:xfrm>
           <a:prstGeom prst="rect">
             <a:avLst/>
@@ -8469,8 +8501,8 @@
         </p:nvSpPr>
         <p:spPr>
           <a:xfrm>
-            <a:off x="1139342" y="6254496"/>
-            <a:ext cx="1280160" cy="292608"/>
+            <a:off x="1365016" y="6272784"/>
+            <a:ext cx="1463040" cy="256032"/>
           </a:xfrm>
           <a:prstGeom prst="rect">
             <a:avLst/>
@@ -8486,7 +8518,7 @@
               <a:buNone/>
             </a:pPr>
             <a:r>
-              <a:rPr lang="en-US" sz="528" b="1" spc="200" kern="0" dirty="0">
+              <a:rPr lang="en-US" sz="504" b="1" spc="150" kern="0" dirty="0">
                 <a:solidFill>
                   <a:srgbClr val="00BCEB"/>
                 </a:solidFill>
@@ -8496,7 +8528,7 @@
               </a:rPr>
               <a:t>SECURE</a:t>
             </a:r>
-            <a:endParaRPr lang="en-US" sz="528" dirty="0"/>
+            <a:endParaRPr lang="en-US" sz="504" dirty="0"/>
           </a:p>
         </p:txBody>
       </p:sp>
@@ -9922,8 +9954,8 @@
         </p:nvSpPr>
         <p:spPr>
           <a:xfrm>
-            <a:off x="863194" y="6254496"/>
-            <a:ext cx="1828800" cy="292608"/>
+            <a:off x="871972" y="6254496"/>
+            <a:ext cx="2194560" cy="292608"/>
           </a:xfrm>
           <a:prstGeom prst="rect">
             <a:avLst/>
@@ -9961,8 +9993,8 @@
         </p:nvSpPr>
         <p:spPr>
           <a:xfrm>
-            <a:off x="1139342" y="6254496"/>
-            <a:ext cx="1280160" cy="292608"/>
+            <a:off x="1365016" y="6272784"/>
+            <a:ext cx="1463040" cy="256032"/>
           </a:xfrm>
           <a:prstGeom prst="rect">
             <a:avLst/>
@@ -9978,7 +10010,7 @@
               <a:buNone/>
             </a:pPr>
             <a:r>
-              <a:rPr lang="en-US" sz="528" b="1" spc="200" kern="0" dirty="0">
+              <a:rPr lang="en-US" sz="504" b="1" spc="150" kern="0" dirty="0">
                 <a:solidFill>
                   <a:srgbClr val="00BCEB"/>
                 </a:solidFill>
@@ -9988,7 +10020,7 @@
               </a:rPr>
               <a:t>SECURE</a:t>
             </a:r>
-            <a:endParaRPr lang="en-US" sz="528" dirty="0"/>
+            <a:endParaRPr lang="en-US" sz="504" dirty="0"/>
           </a:p>
         </p:txBody>
       </p:sp>
@@ -10150,11 +10182,11 @@
         <p:spPr>
           <a:xfrm>
             <a:off x="548640" y="1463040"/>
-            <a:ext cx="3502152" cy="2514600"/>
+            <a:ext cx="3502152" cy="2240280"/>
           </a:xfrm>
           <a:prstGeom prst="roundRect">
             <a:avLst>
-              <a:gd name="adj" fmla="val 4364"/>
+              <a:gd name="adj" fmla="val 4898"/>
             </a:avLst>
           </a:prstGeom>
           <a:solidFill>
@@ -10222,8 +10254,8 @@
         </p:nvSpPr>
         <p:spPr>
           <a:xfrm>
-            <a:off x="804672" y="2084832"/>
-            <a:ext cx="3026664" cy="1737360"/>
+            <a:off x="804672" y="2121408"/>
+            <a:ext cx="3026664" cy="1417320"/>
           </a:xfrm>
           <a:prstGeom prst="rect">
             <a:avLst/>
@@ -10237,7 +10269,7 @@
           <a:p>
             <a:pPr algn="l" indent="0" marL="0">
               <a:lnSpc>
-                <a:spcPct val="103000"/>
+                <a:spcPct val="102000"/>
               </a:lnSpc>
               <a:buNone/>
             </a:pPr>
@@ -10254,10 +10286,10 @@
             </a:r>
             <a:pPr algn="l" indent="0" marL="0">
               <a:lnSpc>
-                <a:spcPct val="103000"/>
+                <a:spcPct val="102000"/>
               </a:lnSpc>
               <a:spcAft>
-                <a:spcPts val="900"/>
+                <a:spcPts val="1100"/>
               </a:spcAft>
               <a:buNone/>
             </a:pPr>
@@ -10270,14 +10302,14 @@
                 <a:ea typeface="Calibri" pitchFamily="34" charset="-122"/>
                 <a:cs typeface="Calibri" pitchFamily="34" charset="-120"/>
               </a:rPr>
-              <a:t>Set up Moodle &amp; groups of 2–4.</a:t>
+              <a:t>Set up Moodle &amp; the groups.</a:t>
             </a:r>
             <a:endParaRPr lang="en-US" sz="1300" dirty="0"/>
           </a:p>
           <a:p>
             <a:pPr algn="l" indent="0" marL="0">
               <a:lnSpc>
-                <a:spcPct val="103000"/>
+                <a:spcPct val="102000"/>
               </a:lnSpc>
               <a:buNone/>
             </a:pPr>
@@ -10294,10 +10326,10 @@
             </a:r>
             <a:pPr algn="l" indent="0" marL="0">
               <a:lnSpc>
-                <a:spcPct val="103000"/>
+                <a:spcPct val="102000"/>
               </a:lnSpc>
               <a:spcAft>
-                <a:spcPts val="900"/>
+                <a:spcPts val="1100"/>
               </a:spcAft>
               <a:buNone/>
             </a:pPr>
@@ -10310,14 +10342,14 @@
                 <a:ea typeface="Calibri" pitchFamily="34" charset="-122"/>
                 <a:cs typeface="Calibri" pitchFamily="34" charset="-120"/>
               </a:rPr>
-              <a:t>State the objective + what good looks like.</a:t>
+              <a:t>State the objective &amp; success.</a:t>
             </a:r>
             <a:endParaRPr lang="en-US" sz="1300" dirty="0"/>
           </a:p>
           <a:p>
             <a:pPr algn="l" indent="0" marL="0">
               <a:lnSpc>
-                <a:spcPct val="103000"/>
+                <a:spcPct val="102000"/>
               </a:lnSpc>
               <a:buNone/>
             </a:pPr>
@@ -10334,10 +10366,10 @@
             </a:r>
             <a:pPr algn="l" indent="0" marL="0">
               <a:lnSpc>
-                <a:spcPct val="103000"/>
+                <a:spcPct val="102000"/>
               </a:lnSpc>
               <a:spcAft>
-                <a:spcPts val="900"/>
+                <a:spcPts val="1100"/>
               </a:spcAft>
               <a:buNone/>
             </a:pPr>
@@ -10365,11 +10397,11 @@
         <p:spPr>
           <a:xfrm>
             <a:off x="4343400" y="1463040"/>
-            <a:ext cx="3502152" cy="2514600"/>
+            <a:ext cx="3502152" cy="2240280"/>
           </a:xfrm>
           <a:prstGeom prst="roundRect">
             <a:avLst>
-              <a:gd name="adj" fmla="val 4364"/>
+              <a:gd name="adj" fmla="val 4898"/>
             </a:avLst>
           </a:prstGeom>
           <a:solidFill>
@@ -10437,8 +10469,8 @@
         </p:nvSpPr>
         <p:spPr>
           <a:xfrm>
-            <a:off x="4599432" y="2084832"/>
-            <a:ext cx="3026664" cy="1737360"/>
+            <a:off x="4599432" y="2121408"/>
+            <a:ext cx="3026664" cy="1417320"/>
           </a:xfrm>
           <a:prstGeom prst="rect">
             <a:avLst/>
@@ -10452,7 +10484,7 @@
           <a:p>
             <a:pPr algn="l" indent="0" marL="0">
               <a:lnSpc>
-                <a:spcPct val="103000"/>
+                <a:spcPct val="102000"/>
               </a:lnSpc>
               <a:buNone/>
             </a:pPr>
@@ -10469,10 +10501,10 @@
             </a:r>
             <a:pPr algn="l" indent="0" marL="0">
               <a:lnSpc>
-                <a:spcPct val="103000"/>
+                <a:spcPct val="102000"/>
               </a:lnSpc>
               <a:spcAft>
-                <a:spcPts val="900"/>
+                <a:spcPts val="1100"/>
               </a:spcAft>
               <a:buNone/>
             </a:pPr>
@@ -10485,14 +10517,14 @@
                 <a:ea typeface="Calibri" pitchFamily="34" charset="-122"/>
                 <a:cs typeface="Calibri" pitchFamily="34" charset="-120"/>
               </a:rPr>
-              <a:t>Circulate; ask “why this product?”.</a:t>
+              <a:t>Circulate; ask “why this?”.</a:t>
             </a:r>
             <a:endParaRPr lang="en-US" sz="1300" dirty="0"/>
           </a:p>
           <a:p>
             <a:pPr algn="l" indent="0" marL="0">
               <a:lnSpc>
-                <a:spcPct val="103000"/>
+                <a:spcPct val="102000"/>
               </a:lnSpc>
               <a:buNone/>
             </a:pPr>
@@ -10509,10 +10541,10 @@
             </a:r>
             <a:pPr algn="l" indent="0" marL="0">
               <a:lnSpc>
-                <a:spcPct val="103000"/>
+                <a:spcPct val="102000"/>
               </a:lnSpc>
               <a:spcAft>
-                <a:spcPts val="900"/>
+                <a:spcPts val="1100"/>
               </a:spcAft>
               <a:buNone/>
             </a:pPr>
@@ -10525,14 +10557,14 @@
                 <a:ea typeface="Calibri" pitchFamily="34" charset="-122"/>
                 <a:cs typeface="Calibri" pitchFamily="34" charset="-120"/>
               </a:rPr>
-              <a:t>Hold pace (~6 min/case); manage load.</a:t>
+              <a:t>Hold ~6 min per case.</a:t>
             </a:r>
             <a:endParaRPr lang="en-US" sz="1300" dirty="0"/>
           </a:p>
           <a:p>
             <a:pPr algn="l" indent="0" marL="0">
               <a:lnSpc>
-                <a:spcPct val="103000"/>
+                <a:spcPct val="102000"/>
               </a:lnSpc>
               <a:buNone/>
             </a:pPr>
@@ -10549,10 +10581,10 @@
             </a:r>
             <a:pPr algn="l" indent="0" marL="0">
               <a:lnSpc>
-                <a:spcPct val="103000"/>
+                <a:spcPct val="102000"/>
               </a:lnSpc>
               <a:spcAft>
-                <a:spcPts val="900"/>
+                <a:spcPts val="1100"/>
               </a:spcAft>
               <a:buNone/>
             </a:pPr>
@@ -10565,7 +10597,7 @@
                 <a:ea typeface="Calibri" pitchFamily="34" charset="-122"/>
                 <a:cs typeface="Calibri" pitchFamily="34" charset="-120"/>
               </a:rPr>
-              <a:t>Keep it safe; ensure everyone submits.</a:t>
+              <a:t>Keep it safe; all submit.</a:t>
             </a:r>
             <a:endParaRPr lang="en-US" sz="1300" dirty="0"/>
           </a:p>
@@ -10580,11 +10612,11 @@
         <p:spPr>
           <a:xfrm>
             <a:off x="8138160" y="1463040"/>
-            <a:ext cx="3502152" cy="2514600"/>
+            <a:ext cx="3502152" cy="2240280"/>
           </a:xfrm>
           <a:prstGeom prst="roundRect">
             <a:avLst>
-              <a:gd name="adj" fmla="val 4364"/>
+              <a:gd name="adj" fmla="val 4898"/>
             </a:avLst>
           </a:prstGeom>
           <a:solidFill>
@@ -10652,8 +10684,8 @@
         </p:nvSpPr>
         <p:spPr>
           <a:xfrm>
-            <a:off x="8394192" y="2084832"/>
-            <a:ext cx="3026664" cy="1737360"/>
+            <a:off x="8394192" y="2121408"/>
+            <a:ext cx="3026664" cy="1417320"/>
           </a:xfrm>
           <a:prstGeom prst="rect">
             <a:avLst/>
@@ -10667,7 +10699,7 @@
           <a:p>
             <a:pPr algn="l" indent="0" marL="0">
               <a:lnSpc>
-                <a:spcPct val="103000"/>
+                <a:spcPct val="102000"/>
               </a:lnSpc>
               <a:buNone/>
             </a:pPr>
@@ -10684,10 +10716,10 @@
             </a:r>
             <a:pPr algn="l" indent="0" marL="0">
               <a:lnSpc>
-                <a:spcPct val="103000"/>
+                <a:spcPct val="102000"/>
               </a:lnSpc>
               <a:spcAft>
-                <a:spcPts val="900"/>
+                <a:spcPts val="1100"/>
               </a:spcAft>
               <a:buNone/>
             </a:pPr>
@@ -10707,7 +10739,7 @@
           <a:p>
             <a:pPr algn="l" indent="0" marL="0">
               <a:lnSpc>
-                <a:spcPct val="103000"/>
+                <a:spcPct val="102000"/>
               </a:lnSpc>
               <a:buNone/>
             </a:pPr>
@@ -10724,10 +10756,10 @@
             </a:r>
             <a:pPr algn="l" indent="0" marL="0">
               <a:lnSpc>
-                <a:spcPct val="103000"/>
+                <a:spcPct val="102000"/>
               </a:lnSpc>
               <a:spcAft>
-                <a:spcPts val="900"/>
+                <a:spcPts val="1100"/>
               </a:spcAft>
               <a:buNone/>
             </a:pPr>
@@ -10747,7 +10779,7 @@
           <a:p>
             <a:pPr algn="l" indent="0" marL="0">
               <a:lnSpc>
-                <a:spcPct val="103000"/>
+                <a:spcPct val="102000"/>
               </a:lnSpc>
               <a:buNone/>
             </a:pPr>
@@ -10764,10 +10796,10 @@
             </a:r>
             <a:pPr algn="l" indent="0" marL="0">
               <a:lnSpc>
-                <a:spcPct val="103000"/>
+                <a:spcPct val="102000"/>
               </a:lnSpc>
               <a:spcAft>
-                <a:spcPts val="900"/>
+                <a:spcPts val="1100"/>
               </a:spcAft>
               <a:buNone/>
             </a:pPr>
@@ -10780,7 +10812,7 @@
                 <a:ea typeface="Calibri" pitchFamily="34" charset="-122"/>
                 <a:cs typeface="Calibri" pitchFamily="34" charset="-120"/>
               </a:rPr>
-              <a:t>Surface one or two exemplars.</a:t>
+              <a:t>Share one or two exemplars.</a:t>
             </a:r>
             <a:endParaRPr lang="en-US" sz="1300" dirty="0"/>
           </a:p>
@@ -10794,12 +10826,12 @@
         </p:nvSpPr>
         <p:spPr>
           <a:xfrm>
-            <a:off x="548640" y="4206240"/>
-            <a:ext cx="5394960" cy="1554480"/>
+            <a:off x="548640" y="4114800"/>
+            <a:ext cx="5394960" cy="1645920"/>
           </a:xfrm>
           <a:prstGeom prst="roundRect">
             <a:avLst>
-              <a:gd name="adj" fmla="val 7059"/>
+              <a:gd name="adj" fmla="val 6667"/>
             </a:avLst>
           </a:prstGeom>
           <a:solidFill>
@@ -10821,7 +10853,7 @@
         </p:nvSpPr>
         <p:spPr>
           <a:xfrm>
-            <a:off x="804672" y="4389120"/>
+            <a:off x="804672" y="4315968"/>
             <a:ext cx="4937760" cy="292608"/>
           </a:xfrm>
           <a:prstGeom prst="rect">
@@ -10860,8 +10892,8 @@
         </p:nvSpPr>
         <p:spPr>
           <a:xfrm>
-            <a:off x="804672" y="4754880"/>
-            <a:ext cx="4919472" cy="914400"/>
+            <a:off x="804672" y="4736592"/>
+            <a:ext cx="4919472" cy="868680"/>
           </a:xfrm>
           <a:prstGeom prst="rect">
             <a:avLst/>
@@ -10888,14 +10920,14 @@
                 <a:ea typeface="Calibri" pitchFamily="34" charset="-122"/>
                 <a:cs typeface="Calibri" pitchFamily="34" charset="-120"/>
               </a:rPr>
-              <a:t>✓  </a:t>
+              <a:t>•  </a:t>
             </a:r>
             <a:pPr algn="l" indent="0" marL="0">
               <a:lnSpc>
                 <a:spcPct val="100000"/>
               </a:lnSpc>
               <a:spcAft>
-                <a:spcPts val="600"/>
+                <a:spcPts val="900"/>
               </a:spcAft>
               <a:buNone/>
             </a:pPr>
@@ -10928,14 +10960,14 @@
                 <a:ea typeface="Calibri" pitchFamily="34" charset="-122"/>
                 <a:cs typeface="Calibri" pitchFamily="34" charset="-120"/>
               </a:rPr>
-              <a:t>✓  </a:t>
+              <a:t>•  </a:t>
             </a:r>
             <a:pPr algn="l" indent="0" marL="0">
               <a:lnSpc>
                 <a:spcPct val="100000"/>
               </a:lnSpc>
               <a:spcAft>
-                <a:spcPts val="600"/>
+                <a:spcPts val="900"/>
               </a:spcAft>
               <a:buNone/>
             </a:pPr>
@@ -10968,14 +11000,14 @@
                 <a:ea typeface="Calibri" pitchFamily="34" charset="-122"/>
                 <a:cs typeface="Calibri" pitchFamily="34" charset="-120"/>
               </a:rPr>
-              <a:t>✓  </a:t>
+              <a:t>•  </a:t>
             </a:r>
             <a:pPr algn="l" indent="0" marL="0">
               <a:lnSpc>
                 <a:spcPct val="100000"/>
               </a:lnSpc>
               <a:spcAft>
-                <a:spcPts val="600"/>
+                <a:spcPts val="900"/>
               </a:spcAft>
               <a:buNone/>
             </a:pPr>
@@ -10988,7 +11020,7 @@
                 <a:ea typeface="Calibri" pitchFamily="34" charset="-122"/>
                 <a:cs typeface="Calibri" pitchFamily="34" charset="-120"/>
               </a:rPr>
-              <a:t>Insist on individual submissions.</a:t>
+              <a:t>Insist on individual answers.</a:t>
             </a:r>
             <a:endParaRPr lang="en-US" sz="1250" dirty="0"/>
           </a:p>
@@ -11002,12 +11034,12 @@
         </p:nvSpPr>
         <p:spPr>
           <a:xfrm>
-            <a:off x="6245352" y="4206240"/>
-            <a:ext cx="5394960" cy="1554480"/>
+            <a:off x="6245352" y="4114800"/>
+            <a:ext cx="5394960" cy="1645920"/>
           </a:xfrm>
           <a:prstGeom prst="roundRect">
             <a:avLst>
-              <a:gd name="adj" fmla="val 7059"/>
+              <a:gd name="adj" fmla="val 6667"/>
             </a:avLst>
           </a:prstGeom>
           <a:solidFill>
@@ -11029,7 +11061,7 @@
         </p:nvSpPr>
         <p:spPr>
           <a:xfrm>
-            <a:off x="6501384" y="4389120"/>
+            <a:off x="6501384" y="4315968"/>
             <a:ext cx="4937760" cy="292608"/>
           </a:xfrm>
           <a:prstGeom prst="rect">
@@ -11068,8 +11100,8 @@
         </p:nvSpPr>
         <p:spPr>
           <a:xfrm>
-            <a:off x="6501384" y="4754880"/>
-            <a:ext cx="4919472" cy="914400"/>
+            <a:off x="6501384" y="4736592"/>
+            <a:ext cx="4919472" cy="868680"/>
           </a:xfrm>
           <a:prstGeom prst="rect">
             <a:avLst/>
@@ -11096,14 +11128,14 @@
                 <a:ea typeface="Calibri" pitchFamily="34" charset="-122"/>
                 <a:cs typeface="Calibri" pitchFamily="34" charset="-120"/>
               </a:rPr>
-              <a:t>✕  </a:t>
+              <a:t>•  </a:t>
             </a:r>
             <a:pPr algn="l" indent="0" marL="0">
               <a:lnSpc>
                 <a:spcPct val="100000"/>
               </a:lnSpc>
               <a:spcAft>
-                <a:spcPts val="600"/>
+                <a:spcPts val="900"/>
               </a:spcAft>
               <a:buNone/>
             </a:pPr>
@@ -11136,14 +11168,14 @@
                 <a:ea typeface="Calibri" pitchFamily="34" charset="-122"/>
                 <a:cs typeface="Calibri" pitchFamily="34" charset="-120"/>
               </a:rPr>
-              <a:t>✕  </a:t>
+              <a:t>•  </a:t>
             </a:r>
             <a:pPr algn="l" indent="0" marL="0">
               <a:lnSpc>
                 <a:spcPct val="100000"/>
               </a:lnSpc>
               <a:spcAft>
-                <a:spcPts val="600"/>
+                <a:spcPts val="900"/>
               </a:spcAft>
               <a:buNone/>
             </a:pPr>
@@ -11176,14 +11208,14 @@
                 <a:ea typeface="Calibri" pitchFamily="34" charset="-122"/>
                 <a:cs typeface="Calibri" pitchFamily="34" charset="-120"/>
               </a:rPr>
-              <a:t>✕  </a:t>
+              <a:t>•  </a:t>
             </a:r>
             <a:pPr algn="l" indent="0" marL="0">
               <a:lnSpc>
                 <a:spcPct val="100000"/>
               </a:lnSpc>
               <a:spcAft>
-                <a:spcPts val="600"/>
+                <a:spcPts val="900"/>
               </a:spcAft>
               <a:buNone/>
             </a:pPr>
@@ -11452,8 +11484,8 @@
         </p:nvSpPr>
         <p:spPr>
           <a:xfrm>
-            <a:off x="863194" y="6254496"/>
-            <a:ext cx="1828800" cy="292608"/>
+            <a:off x="871972" y="6254496"/>
+            <a:ext cx="2194560" cy="292608"/>
           </a:xfrm>
           <a:prstGeom prst="rect">
             <a:avLst/>
@@ -11491,8 +11523,8 @@
         </p:nvSpPr>
         <p:spPr>
           <a:xfrm>
-            <a:off x="1139342" y="6254496"/>
-            <a:ext cx="1280160" cy="292608"/>
+            <a:off x="1365016" y="6272784"/>
+            <a:ext cx="1463040" cy="256032"/>
           </a:xfrm>
           <a:prstGeom prst="rect">
             <a:avLst/>
@@ -11508,7 +11540,7 @@
               <a:buNone/>
             </a:pPr>
             <a:r>
-              <a:rPr lang="en-US" sz="528" b="1" spc="200" kern="0" dirty="0">
+              <a:rPr lang="en-US" sz="504" b="1" spc="150" kern="0" dirty="0">
                 <a:solidFill>
                   <a:srgbClr val="00BCEB"/>
                 </a:solidFill>
@@ -11518,7 +11550,7 @@
               </a:rPr>
               <a:t>SECURE</a:t>
             </a:r>
-            <a:endParaRPr lang="en-US" sz="528" dirty="0"/>
+            <a:endParaRPr lang="en-US" sz="504" dirty="0"/>
           </a:p>
         </p:txBody>
       </p:sp>
@@ -11680,11 +11712,11 @@
         <p:spPr>
           <a:xfrm>
             <a:off x="548640" y="1463040"/>
-            <a:ext cx="5486400" cy="2834640"/>
+            <a:ext cx="5486400" cy="2423160"/>
           </a:xfrm>
           <a:prstGeom prst="roundRect">
             <a:avLst>
-              <a:gd name="adj" fmla="val 4516"/>
+              <a:gd name="adj" fmla="val 5283"/>
             </a:avLst>
           </a:prstGeom>
           <a:solidFill>
@@ -11752,8 +11784,8 @@
         </p:nvSpPr>
         <p:spPr>
           <a:xfrm>
-            <a:off x="822960" y="2103120"/>
-            <a:ext cx="4937760" cy="2057400"/>
+            <a:off x="822960" y="2084832"/>
+            <a:ext cx="4937760" cy="1691640"/>
           </a:xfrm>
           <a:prstGeom prst="rect">
             <a:avLst/>
@@ -11767,7 +11799,7 @@
           <a:p>
             <a:pPr algn="l" indent="0" marL="0">
               <a:lnSpc>
-                <a:spcPct val="103000"/>
+                <a:spcPct val="102000"/>
               </a:lnSpc>
               <a:buNone/>
             </a:pPr>
@@ -11780,14 +11812,14 @@
                 <a:ea typeface="Calibri" pitchFamily="34" charset="-122"/>
                 <a:cs typeface="Calibri" pitchFamily="34" charset="-120"/>
               </a:rPr>
-              <a:t>✓  </a:t>
+              <a:t>•  </a:t>
             </a:r>
             <a:pPr algn="l" indent="0" marL="0">
               <a:lnSpc>
-                <a:spcPct val="103000"/>
+                <a:spcPct val="102000"/>
               </a:lnSpc>
               <a:spcAft>
-                <a:spcPts val="1000"/>
+                <a:spcPts val="900"/>
               </a:spcAft>
               <a:buNone/>
             </a:pPr>
@@ -11800,14 +11832,14 @@
                 <a:ea typeface="Calibri" pitchFamily="34" charset="-122"/>
                 <a:cs typeface="Calibri" pitchFamily="34" charset="-120"/>
               </a:rPr>
-              <a:t>Tables arranged for groups of 2–4.</a:t>
+              <a:t>Tables set for groups of 2–4.</a:t>
             </a:r>
             <a:endParaRPr lang="en-US" sz="1350" dirty="0"/>
           </a:p>
           <a:p>
             <a:pPr algn="l" indent="0" marL="0">
               <a:lnSpc>
-                <a:spcPct val="103000"/>
+                <a:spcPct val="102000"/>
               </a:lnSpc>
               <a:buNone/>
             </a:pPr>
@@ -11820,14 +11852,14 @@
                 <a:ea typeface="Calibri" pitchFamily="34" charset="-122"/>
                 <a:cs typeface="Calibri" pitchFamily="34" charset="-120"/>
               </a:rPr>
-              <a:t>✓  </a:t>
+              <a:t>•  </a:t>
             </a:r>
             <a:pPr algn="l" indent="0" marL="0">
               <a:lnSpc>
-                <a:spcPct val="103000"/>
+                <a:spcPct val="102000"/>
               </a:lnSpc>
               <a:spcAft>
-                <a:spcPts val="1000"/>
+                <a:spcPts val="900"/>
               </a:spcAft>
               <a:buNone/>
             </a:pPr>
@@ -11840,14 +11872,14 @@
                 <a:ea typeface="Calibri" pitchFamily="34" charset="-122"/>
                 <a:cs typeface="Calibri" pitchFamily="34" charset="-120"/>
               </a:rPr>
-              <a:t>A device per participant (for Moodle).</a:t>
+              <a:t>A device per participant.</a:t>
             </a:r>
             <a:endParaRPr lang="en-US" sz="1350" dirty="0"/>
           </a:p>
           <a:p>
             <a:pPr algn="l" indent="0" marL="0">
               <a:lnSpc>
-                <a:spcPct val="103000"/>
+                <a:spcPct val="102000"/>
               </a:lnSpc>
               <a:buNone/>
             </a:pPr>
@@ -11860,14 +11892,14 @@
                 <a:ea typeface="Calibri" pitchFamily="34" charset="-122"/>
                 <a:cs typeface="Calibri" pitchFamily="34" charset="-120"/>
               </a:rPr>
-              <a:t>✓  </a:t>
+              <a:t>•  </a:t>
             </a:r>
             <a:pPr algn="l" indent="0" marL="0">
               <a:lnSpc>
-                <a:spcPct val="103000"/>
+                <a:spcPct val="102000"/>
               </a:lnSpc>
               <a:spcAft>
-                <a:spcPts val="1000"/>
+                <a:spcPts val="900"/>
               </a:spcAft>
               <a:buNone/>
             </a:pPr>
@@ -11887,7 +11919,7 @@
           <a:p>
             <a:pPr algn="l" indent="0" marL="0">
               <a:lnSpc>
-                <a:spcPct val="103000"/>
+                <a:spcPct val="102000"/>
               </a:lnSpc>
               <a:buNone/>
             </a:pPr>
@@ -11900,14 +11932,14 @@
                 <a:ea typeface="Calibri" pitchFamily="34" charset="-122"/>
                 <a:cs typeface="Calibri" pitchFamily="34" charset="-120"/>
               </a:rPr>
-              <a:t>✓  </a:t>
+              <a:t>•  </a:t>
             </a:r>
             <a:pPr algn="l" indent="0" marL="0">
               <a:lnSpc>
-                <a:spcPct val="103000"/>
+                <a:spcPct val="102000"/>
               </a:lnSpc>
               <a:spcAft>
-                <a:spcPts val="1000"/>
+                <a:spcPts val="900"/>
               </a:spcAft>
               <a:buNone/>
             </a:pPr>
@@ -11927,7 +11959,7 @@
           <a:p>
             <a:pPr algn="l" indent="0" marL="0">
               <a:lnSpc>
-                <a:spcPct val="103000"/>
+                <a:spcPct val="102000"/>
               </a:lnSpc>
               <a:buNone/>
             </a:pPr>
@@ -11940,14 +11972,14 @@
                 <a:ea typeface="Calibri" pitchFamily="34" charset="-122"/>
                 <a:cs typeface="Calibri" pitchFamily="34" charset="-120"/>
               </a:rPr>
-              <a:t>✓  </a:t>
+              <a:t>•  </a:t>
             </a:r>
             <a:pPr algn="l" indent="0" marL="0">
               <a:lnSpc>
-                <a:spcPct val="103000"/>
+                <a:spcPct val="102000"/>
               </a:lnSpc>
               <a:spcAft>
-                <a:spcPts val="1000"/>
+                <a:spcPts val="900"/>
               </a:spcAft>
               <a:buNone/>
             </a:pPr>
@@ -11960,7 +11992,7 @@
                 <a:ea typeface="Calibri" pitchFamily="34" charset="-122"/>
                 <a:cs typeface="Calibri" pitchFamily="34" charset="-120"/>
               </a:rPr>
-              <a:t>45 minutes; scored automatically in Moodle.</a:t>
+              <a:t>Scored automatically in Moodle.</a:t>
             </a:r>
             <a:endParaRPr lang="en-US" sz="1350" dirty="0"/>
           </a:p>
@@ -16590,7 +16622,7 @@
         </p:nvSpPr>
         <p:spPr>
           <a:xfrm>
-            <a:off x="6245352" y="2971800"/>
+            <a:off x="6245352" y="3063240"/>
             <a:ext cx="5394960" cy="1325880"/>
           </a:xfrm>
           <a:prstGeom prst="roundRect">
@@ -16624,7 +16656,7 @@
         </p:nvSpPr>
         <p:spPr>
           <a:xfrm>
-            <a:off x="6519672" y="3154680"/>
+            <a:off x="6519672" y="3246120"/>
             <a:ext cx="3840480" cy="365760"/>
           </a:xfrm>
           <a:prstGeom prst="rect">
@@ -16663,7 +16695,7 @@
         </p:nvSpPr>
         <p:spPr>
           <a:xfrm>
-            <a:off x="9418320" y="3200400"/>
+            <a:off x="9464040" y="3291840"/>
             <a:ext cx="974750" cy="237744"/>
           </a:xfrm>
           <a:prstGeom prst="roundRect">
@@ -16685,7 +16717,7 @@
         </p:nvSpPr>
         <p:spPr>
           <a:xfrm>
-            <a:off x="9418320" y="3200400"/>
+            <a:off x="9464040" y="3291840"/>
             <a:ext cx="974750" cy="237744"/>
           </a:xfrm>
           <a:prstGeom prst="rect">
@@ -16724,7 +16756,7 @@
         </p:nvSpPr>
         <p:spPr>
           <a:xfrm>
-            <a:off x="6519672" y="3566160"/>
+            <a:off x="6519672" y="3675888"/>
             <a:ext cx="4937760" cy="640080"/>
           </a:xfrm>
           <a:prstGeom prst="rect">
@@ -16739,7 +16771,7 @@
           <a:p>
             <a:pPr algn="l" indent="0" marL="0">
               <a:lnSpc>
-                <a:spcPct val="115000"/>
+                <a:spcPct val="120000"/>
               </a:lnSpc>
               <a:buNone/>
             </a:pPr>
@@ -16752,12 +16784,14 @@
                 <a:ea typeface="Calibri" pitchFamily="34" charset="-122"/>
                 <a:cs typeface="Calibri" pitchFamily="34" charset="-120"/>
               </a:rPr>
-              <a:t>https://circuit-convertor.example.com
-</a:t>
-            </a:r>
+              <a:t>https://circuit-convertor.example.com</a:t>
+            </a:r>
+            <a:endParaRPr lang="en-US" sz="1150" dirty="0"/>
+          </a:p>
+          <a:p>
             <a:pPr algn="l" indent="0" marL="0">
               <a:lnSpc>
-                <a:spcPct val="115000"/>
+                <a:spcPct val="120000"/>
               </a:lnSpc>
               <a:buNone/>
             </a:pPr>
@@ -17068,8 +17102,8 @@
         </p:nvSpPr>
         <p:spPr>
           <a:xfrm>
-            <a:off x="902513" y="5870448"/>
-            <a:ext cx="1828800" cy="310896"/>
+            <a:off x="912388" y="5870448"/>
+            <a:ext cx="2194560" cy="310896"/>
           </a:xfrm>
           <a:prstGeom prst="rect">
             <a:avLst/>
@@ -17107,8 +17141,8 @@
         </p:nvSpPr>
         <p:spPr>
           <a:xfrm>
-            <a:off x="1191006" y="5870448"/>
-            <a:ext cx="1280160" cy="310896"/>
+            <a:off x="1434328" y="5888736"/>
+            <a:ext cx="1463040" cy="274320"/>
           </a:xfrm>
           <a:prstGeom prst="rect">
             <a:avLst/>
@@ -17124,7 +17158,7 @@
               <a:buNone/>
             </a:pPr>
             <a:r>
-              <a:rPr lang="en-US" sz="572" b="1" spc="200" kern="0" dirty="0">
+              <a:rPr lang="en-US" sz="546" b="1" spc="150" kern="0" dirty="0">
                 <a:solidFill>
                   <a:srgbClr val="00BCEB"/>
                 </a:solidFill>
@@ -17134,7 +17168,7 @@
               </a:rPr>
               <a:t>SECURE</a:t>
             </a:r>
-            <a:endParaRPr lang="en-US" sz="572" dirty="0"/>
+            <a:endParaRPr lang="en-US" sz="546" dirty="0"/>
           </a:p>
         </p:txBody>
       </p:sp>

</xml_diff>